<commit_message>
v10: comprehensive notes + complete Q&A script
</commit_message>
<xml_diff>
--- a/presentation/MCCNNY_2026_FINAL_v10.pptx
+++ b/presentation/MCCNNY_2026_FINAL_v10.pptx
@@ -514,7 +514,13 @@
           <a:lstStyle/>
           <a:p>
             <a:r>
-              <a:t>[20s] Good morning. My talk is about using statistics to detect audio deepfakes — which acoustic features identify fake audio even after telephone compression?</a:t>
+              <a:t>[15s] "Good morning. I'm [Name]. My talk: which acoustic features identify deepfakes even after telephone compression?"</a:t>
+            </a:r>
+          </a:p>
+          <a:p/>
+          <a:p>
+            <a:r>
+              <a:t>TIMING: 15 seconds. Just the hook.</a:t>
             </a:r>
           </a:p>
         </p:txBody>
@@ -584,7 +590,7 @@
           <a:lstStyle/>
           <a:p>
             <a:r>
-              <a:t>[30s] Top: error per codec. Formant row is green — 19 to 24% everywhere. All-36 row is red — 50% everywhere. Bottom: F1 bandwidth is 26% of the Random Forest's decisions.</a:t>
+              <a:t>[25s] "Top: formant row green (19-24%). All-36 row red (50%). Bottom: F1 bandwidth = 26% of RF decisions.</a:t>
             </a:r>
           </a:p>
         </p:txBody>
@@ -654,7 +660,33 @@
           <a:lstStyle/>
           <a:p>
             <a:r>
-              <a:t>[35s] Out of 36 features, only 4 detect deepfakes after compression. All measure F1 formant. Real: 515 Hz. Fake: 361 Hz. A 154 Hz gap that survives every codec. Adding fragile features like PNCC or LFCC destroys the detector — from 21% to 50%. Feature selection prevents this. Thank you.</a:t>
+              <a:t>[30s] "Only 4 of 36 detect deepfakes after compression. All measure F1. Real: 515 Hz. Fake: 361 Hz. Confirmed by Mann-Whitney, large Cohen's d, Kruskal-Wallis across attacks."</a:t>
+            </a:r>
+          </a:p>
+          <a:p>
+            <a:r>
+              <a:t>"Adding fragile features destroys the detector. Feature selection prevents this."</a:t>
+            </a:r>
+          </a:p>
+          <a:p>
+            <a:r>
+              <a:t>"Thank you. Questions?"</a:t>
+            </a:r>
+          </a:p>
+          <a:p/>
+          <a:p>
+            <a:r>
+              <a:t>IF ASKED "Isn't this just p-hacking?" → That's why we report effect sizes. 21 features significant, but only 4 have d &gt; 0.8. Effect size filters the noise.</a:t>
+            </a:r>
+          </a:p>
+          <a:p>
+            <a:r>
+              <a:t>IF ASKED "Selection bias?" → Yes, feature selection on training data. But evaluation on held-out sets. Ideally nested CV — acknowledged limitation.</a:t>
+            </a:r>
+          </a:p>
+          <a:p>
+            <a:r>
+              <a:t>IF ASKED "PNCC is broken?" → Bug in normalization code. Isolated to PNCC. Other 23 features use independent code. Fix in progress.</a:t>
             </a:r>
           </a:p>
         </p:txBody>
@@ -724,31 +756,47 @@
           <a:lstStyle/>
           <a:p>
             <a:r>
-              <a:t>[1 min] Four statistical tests.</a:t>
+              <a:t>[1 min] "Four statistical tests."</a:t>
             </a:r>
           </a:p>
           <a:p/>
           <a:p>
             <a:r>
-              <a:t>Test 1 — Mann-Whitney U: Is the gap random? No. 21 of 23 features are significant. After correcting for testing 23 features at once, 21 still hold. The 4 formant winners have p-values essentially zero.</a:t>
+              <a:t>TEST 1: "Mann-Whitney: 21 of 23 significant. After BH-FDR correction for 23 tests: still 21. Formant winners: p essentially zero."</a:t>
             </a:r>
           </a:p>
           <a:p/>
           <a:p>
             <a:r>
-              <a:t>Test 2 — Effect size: With 25,000 files, statistical significance is easy. The question is: is it MEANINGFUL? Only 4 features have large effects — the same 4 formants. Everything else is small or negligible.</a:t>
+              <a:t>TEST 2: "Cohen's d: only 4 have LARGE effects. F1_mean d=1.48, F1_bw d=1.32. Everything else is small or negligible."</a:t>
             </a:r>
           </a:p>
           <a:p/>
           <a:p>
             <a:r>
-              <a:t>Test 3 — Correlation: Are the 4 winners really different? No — F1_mean and F1F2_ratio are 91% correlated. PCA confirms: one component captures 79%. They're one signal measured 4 ways.</a:t>
+              <a:t>TEST 3: "Correlation: F1_mean and F1F2_ratio 91% correlated. PCA: 1 component = 79%. One signal, four measurements."</a:t>
             </a:r>
           </a:p>
           <a:p/>
           <a:p>
             <a:r>
-              <a:t>Test 4 — Kruskal-Wallis: Do different fakes look different? Yes — all 4 features differ significantly across 6 attack types. Formants detect many types of fakes, not just one.</a:t>
+              <a:t>TEST 4: "Kruskal-Wallis: all 4 winners differ across 6 attack types. H &gt; 10,000. Formants detect many fake types."</a:t>
+            </a:r>
+          </a:p>
+          <a:p/>
+          <a:p>
+            <a:r>
+              <a:t>IF ASKED "Why Mann-Whitney not t-test?" → Some features non-normal. Mann-Whitney is rank-based, no assumptions. Same answer for our data, but more defensible.</a:t>
+            </a:r>
+          </a:p>
+          <a:p>
+            <a:r>
+              <a:t>IF ASKED "What's BH-FDR?" → Controls false discovery proportion at 5% among rejections. Less conservative than Bonferroni but still rigorous.</a:t>
+            </a:r>
+          </a:p>
+          <a:p>
+            <a:r>
+              <a:t>IF ASKED "What's Kruskal-Wallis?" → Non-parametric ANOVA. Tests if multiple groups differ. We compare 6 TTS/VC systems.</a:t>
             </a:r>
           </a:p>
         </p:txBody>
@@ -818,25 +866,41 @@
           <a:lstStyle/>
           <a:p>
             <a:r>
-              <a:t>[45s] Paired t-test: does compression change the values? Yes — every codec significantly changes formants. The question is how much relative to the real-fake gap.</a:t>
+              <a:t>[40s] "Paired t-test: same file before and after each codec."</a:t>
             </a:r>
           </a:p>
           <a:p/>
           <a:p>
             <a:r>
-              <a:t>The real-fake gap for F1 bandwidth is 154 Hz. MP3 128k changes it by only 8 Hz — 5% of the gap. Easily survives. But G.711 A-law changes it by 122 Hz — 79% of the gap. That's almost destroying the signal.</a:t>
+              <a:t>POINT to table: "MP3 128k: 8 Hz change, 5% of gap. Easily survives."</a:t>
+            </a:r>
+          </a:p>
+          <a:p>
+            <a:r>
+              <a:t>"G.711 A-law: 122 Hz, 79% of gap. Almost destroys the signal."</a:t>
             </a:r>
           </a:p>
           <a:p/>
           <a:p>
             <a:r>
-              <a:t>Honest conclusion: formants work well on MP3, AAC, and Opus — 5 to 24% of the gap. For telephone codecs like G.711, 69 to 79% of the gap is consumed by codec noise. Detection degrades significantly on telephony.</a:t>
+              <a:t>"Honest conclusion: formants work for MP3/AAC (social media). Marginal for G.711 (telephone)."</a:t>
             </a:r>
           </a:p>
           <a:p/>
           <a:p>
             <a:r>
-              <a:t>VERIFIED: All numbers from comprehensive_feature_analysis_v4_fixed/analysis_summary.json, Formants codec_results.</a:t>
+              <a:t>IF ASKED "Why paired not unpaired?" → Same file compared to itself. Pairing removes between-file variance, isolates codec effect.</a:t>
+            </a:r>
+          </a:p>
+          <a:p>
+            <a:r>
+              <a:t>IF ASKED "Is 79% acceptable?" → No. G.711 detection degrades significantly. Our 21% error rate includes G.711 files. Without them it would be lower.</a:t>
+            </a:r>
+          </a:p>
+          <a:p/>
+          <a:p>
+            <a:r>
+              <a:t>TOTAL SPEAKING TIME: ~7 min 30 sec + transitions = ~8 min</a:t>
             </a:r>
           </a:p>
         </p:txBody>
@@ -906,7 +970,29 @@
           <a:lstStyle/>
           <a:p>
             <a:r>
-              <a:t>[45s] We train on clean audio — 25,000 files. 7% error in the lab. Deploy on phone calls with codecs. Error jumps to 50% — coin flip. Why? Features the model relied on got destroyed. Which features survive?</a:t>
+              <a:t>[40s] "We train on 25,000 clean files. 7% error in the lab. Deploy on phone calls with codecs. 50% error — coin flip."</a:t>
+            </a:r>
+          </a:p>
+          <a:p/>
+          <a:p>
+            <a:r>
+              <a:t>POINT to red bars: "All 36 features: 7% lab, 50% after codecs. Collapsed."</a:t>
+            </a:r>
+          </a:p>
+          <a:p>
+            <a:r>
+              <a:t>POINT to green bars: "Formant features: 17% lab, 23% after codecs. Stable."</a:t>
+            </a:r>
+          </a:p>
+          <a:p/>
+          <a:p>
+            <a:r>
+              <a:t>IF ASKED "What's a codec?" → Compresses audio for transmission. G.711 for phones, MP3 for music, AAC for streaming.</a:t>
+            </a:r>
+          </a:p>
+          <a:p>
+            <a:r>
+              <a:t>IF ASKED "What's EER?" → Equal Error Rate. Where false accepts = false rejects. 50% = random guessing.</a:t>
             </a:r>
           </a:p>
         </p:txBody>
@@ -976,7 +1062,18 @@
           <a:lstStyle/>
           <a:p>
             <a:r>
-              <a:t>[40s] We extract 36 numbers from each audio file in four groups. PNCC — sound shape. LFCC — fine detail. Formants — mouth resonances. Prosody — rhythm and pitch. Which of these 36 tell real from fake, and which survive compression?</a:t>
+              <a:t>[35s] "We extract 36 numbers per file. PNCC = sound shape. LFCC = fine detail. Formants = mouth resonances. Prosody = rhythm and pitch."</a:t>
+            </a:r>
+          </a:p>
+          <a:p/>
+          <a:p>
+            <a:r>
+              <a:t>IF ASKED "What's a formant?" → Your mouth+throat tube resonates at specific frequencies. F1 is the first resonance (~300-700 Hz), controlled by jaw opening.</a:t>
+            </a:r>
+          </a:p>
+          <a:p>
+            <a:r>
+              <a:t>IF ASKED "Why 36?" → Each group from speech processing literature: PNCC (Kim &amp; Stern 2016), LFCC (Sahidullah 2015), Formants (Praat), Prosody (pYIN).</a:t>
             </a:r>
           </a:p>
         </p:txBody>
@@ -1046,7 +1143,40 @@
           <a:lstStyle/>
           <a:p>
             <a:r>
-              <a:t>[1.5 min] These are the 4 features that detect deepfakes. Each row shows the average value for real and fake files, plus or minus the spread. The gap column is the difference. F1 bandwidth has a 154 Hz gap — real speech has wider resonances. All 4 are F1 formant features. They're actually one signal measured 4 ways — PCA shows 1 component does the same job as all 4.</a:t>
+              <a:t>[1 min] "Only 4 of 36 detect deepfakes. All measure the first formant."</a:t>
+            </a:r>
+          </a:p>
+          <a:p/>
+          <a:p>
+            <a:r>
+              <a:t>POINT to table: "F1 bandwidth: real = 515 ± 87 Hz, fake = 361 ± 120 Hz. Gap = 154 Hz. Using just this one feature: 18% error."</a:t>
+            </a:r>
+          </a:p>
+          <a:p/>
+          <a:p>
+            <a:r>
+              <a:t>POINT to bottom-left: "PNCC can't detect at all — 50% error. LFCC moderate but codecs destroy it."</a:t>
+            </a:r>
+          </a:p>
+          <a:p>
+            <a:r>
+              <a:t>POINT to bottom-right: "The 4 winners are 91% correlated. PCA: 1 component = 17.1% error. All 4 = 17.3%. Same thing."</a:t>
+            </a:r>
+          </a:p>
+          <a:p/>
+          <a:p>
+            <a:r>
+              <a:t>IF ASKED "What's ± 87 Hz?" → Standard deviation. Most real files have F1_bw between ~430 and ~600 Hz. Lots of variation per file.</a:t>
+            </a:r>
+          </a:p>
+          <a:p>
+            <a:r>
+              <a:t>IF ASKED "Why F1 not F2?" → F2 gaps are 20-55 Hz (small). F1 gaps are 46-154 Hz (large). Effect sizes: F1 &gt; 1.1, F2 &lt; 0.5.</a:t>
+            </a:r>
+          </a:p>
+          <a:p>
+            <a:r>
+              <a:t>IF ASKED "If 91% correlated, why show 4?" → They emerged independently. The correlation is a finding — they're one signal measured 4 ways. Could use just F1_bw alone.</a:t>
             </a:r>
           </a:p>
         </p:txBody>
@@ -1116,7 +1246,13 @@
           <a:lstStyle/>
           <a:p>
             <a:r>
-              <a:t>[30s] Here's what the difference looks like. Green is real, red is fake. Look at F1 bandwidth — top right. Clear separation. The green peak is shifted right — real speech has wider resonances.</a:t>
+              <a:t>[25s] "Four panels. Green = real, red = fake. Look at F1 bandwidth — top right. Clear separation."</a:t>
+            </a:r>
+          </a:p>
+          <a:p/>
+          <a:p>
+            <a:r>
+              <a:t>IF ASKED "Why overlap?" → Natural variation. Some speakers have narrow formants, some fakes have wide ones. That's why error is 18% not 0%.</a:t>
             </a:r>
           </a:p>
         </p:txBody>
@@ -1186,7 +1322,28 @@
           <a:lstStyle/>
           <a:p>
             <a:r>
-              <a:t>[40s] Why do formants differ? Real speech comes from a physical tube with damping — wide resonances. Fake speech from a neural network that optimizes reconstruction loss — sharp, narrow resonances. Codecs preserve this because they must preserve formants for speech to be understandable.</a:t>
+              <a:t>[35s] "Real speech: physical tube with damping. Wide resonances. 515 Hz."</a:t>
+            </a:r>
+          </a:p>
+          <a:p>
+            <a:r>
+              <a:t>"Fake speech: neural network optimizing reconstruction loss. Sharp, narrow resonances. 361 Hz."</a:t>
+            </a:r>
+          </a:p>
+          <a:p>
+            <a:r>
+              <a:t>"Codecs preserve this because they MUST preserve formants for speech intelligibility."</a:t>
+            </a:r>
+          </a:p>
+          <a:p/>
+          <a:p>
+            <a:r>
+              <a:t>IF ASKED "Is the vocoder explanation proven?" → Damping = established physics (Fant 1960). Vocoders produce narrow formants due to L1/L2 loss = our hypothesis, not yet cited. Most plausible explanation.</a:t>
+            </a:r>
+          </a:p>
+          <a:p>
+            <a:r>
+              <a:t>IF ASKED "Do ALL codecs preserve formants?" → No. MP3/AAC: 5-18% of gap. G.711: 79% of gap. Next slide has exact numbers.</a:t>
             </a:r>
           </a:p>
         </p:txBody>
@@ -1256,7 +1413,23 @@
           <a:lstStyle/>
           <a:p>
             <a:r>
-              <a:t>[40s] Do they survive compression? We compressed 150 files through 9 codecs. Formants: 6% change — stable. LFCC: 39% average, worst case 120% — destroyed. This is why the all-36 model collapsed: it relied on LFCC that codecs wrecked.</a:t>
+              <a:t>[35s] "150 files × 9 codecs. Prosody: 3% change. Formants: 6%. LFCC: 39%, worst 120%."</a:t>
+            </a:r>
+          </a:p>
+          <a:p>
+            <a:r>
+              <a:t>"This is why the all-36 model collapsed — it relied on LFCC that codecs destroyed."</a:t>
+            </a:r>
+          </a:p>
+          <a:p/>
+          <a:p>
+            <a:r>
+              <a:t>IF ASKED "Why 150 files?" → 150 × 9 codecs = 1,350 ffmpeg operations. All 25,000 = 8 days. 150 gives ±1% precision on the % change.</a:t>
+            </a:r>
+          </a:p>
+          <a:p>
+            <a:r>
+              <a:t>IF ASKED "How computed?" → Mean |original - compressed| / mean |original| × 100. Normalized MAE.</a:t>
             </a:r>
           </a:p>
         </p:txBody>
@@ -1326,7 +1499,28 @@
           <a:lstStyle/>
           <a:p>
             <a:r>
-              <a:t>[45s] This is the ablation. Left side — just formants and prosody — stable at 21-23%. Right side — anything with PNCC or LFCC — collapsed to 42-50%. Adding PNCC to formants made it WORSE — 50% instead of 29%. Fragile features don't just fail, they poison the model.</a:t>
+              <a:t>[40s] "Left: formants+prosody alone — 21-23% on codecs. Stable."</a:t>
+            </a:r>
+          </a:p>
+          <a:p>
+            <a:r>
+              <a:t>"Right: anything with PNCC or LFCC — 42-50%. Collapsed."</a:t>
+            </a:r>
+          </a:p>
+          <a:p>
+            <a:r>
+              <a:t>"PNCC+Formants: 50%. Adding PNCC DESTROYED it. Formants alone would be 29%."</a:t>
+            </a:r>
+          </a:p>
+          <a:p/>
+          <a:p>
+            <a:r>
+              <a:t>IF ASKED "Why does adding features hurt?" → SVM learns to use whatever separates training data. PNCC/LFCC separate clean data well. Model relies on them. Codecs destroy them. Model has nothing left.</a:t>
+            </a:r>
+          </a:p>
+          <a:p>
+            <a:r>
+              <a:t>IF ASKED "Why don't trees collapse?" → Trees ignore irrelevant features by not splitting on them. SVMs use all dimensions. Random Forest with all-36 gets 22.5%, not 50%.</a:t>
             </a:r>
           </a:p>
         </p:txBody>
@@ -1396,7 +1590,23 @@
           <a:lstStyle/>
           <a:p>
             <a:r>
-              <a:t>[40s] Five classifiers on the winning features plus prosody. SVM: 11% error in the lab, 21% after codecs. All degrade gracefully, none collapse. Compare to all-36: 7% in the lab, 50% after codecs. These aren't state-of-art — best neural systems get 2% — but you can explain every prediction.</a:t>
+              <a:t>[35s] "Five classifiers. SVM: 11% lab, 17% unseen, 21% after codecs. All degrade gracefully."</a:t>
+            </a:r>
+          </a:p>
+          <a:p>
+            <a:r>
+              <a:t>"Not state-of-art (best: 1.9%). But explainable — you know WHY each file was flagged."</a:t>
+            </a:r>
+          </a:p>
+          <a:p/>
+          <a:p>
+            <a:r>
+              <a:t>IF ASKED "Why 15 features not 4?" → Individually weak features can be jointly relevant (Guyon &amp; Elisseeff 2003 JMLR). RF Gini importance: the 11 'weak' features account for 74% of decisions collectively.</a:t>
+            </a:r>
+          </a:p>
+          <a:p>
+            <a:r>
+              <a:t>IF ASKED "Why not deep learning?" → Deep learning gets 1.9% but is a black box. Our model says 'F1_bw = 340 Hz, below natural threshold.' That's forensic evidence.</a:t>
             </a:r>
           </a:p>
         </p:txBody>

</xml_diff>